<commit_message>
Add ASELSAN presentation template and update slides
</commit_message>
<xml_diff>
--- a/Faz_Gurultusu_Capraz_Korelasyon_Sunumu.pptx
+++ b/Faz_Gurultusu_Capraz_Korelasyon_Sunumu.pptx
@@ -13473,7 +13473,7 @@
                 <a:ea typeface="DejaVu Sans Mono"/>
                 <a:cs typeface="DejaVu Sans Mono"/>
               </a:rPr>
-              <a:t>20</a:t>
+              <a:t>19</a:t>
             </a:r>
             <a:endParaRPr sz="1275" b="1" i="0" dirty="0">
               <a:solidFill>
@@ -16090,7 +16090,7 @@
                 <a:ea typeface="DejaVu Sans Mono"/>
                 <a:cs typeface="DejaVu Sans Mono"/>
               </a:rPr>
-              <a:t>21</a:t>
+              <a:t>20</a:t>
             </a:r>
             <a:endParaRPr sz="1275" b="1" i="0" dirty="0">
               <a:solidFill>
@@ -17355,7 +17355,7 @@
                 <a:ea typeface="DejaVu Sans Mono"/>
                 <a:cs typeface="DejaVu Sans Mono"/>
               </a:rPr>
-              <a:t>22</a:t>
+              <a:t>21</a:t>
             </a:r>
             <a:endParaRPr sz="1275" b="1" i="0" dirty="0">
               <a:solidFill>
@@ -19029,7 +19029,7 @@
                 <a:ea typeface="DejaVu Sans Mono"/>
                 <a:cs typeface="DejaVu Sans Mono"/>
               </a:rPr>
-              <a:t>23</a:t>
+              <a:t>22</a:t>
             </a:r>
             <a:endParaRPr sz="1275" b="1" i="0" dirty="0">
               <a:solidFill>
@@ -19785,7 +19785,7 @@
                 <a:ea typeface="DejaVu Sans Mono"/>
                 <a:cs typeface="DejaVu Sans Mono"/>
               </a:rPr>
-              <a:t>24</a:t>
+              <a:t>23</a:t>
             </a:r>
             <a:endParaRPr sz="1275" b="1" i="0" dirty="0">
               <a:solidFill>
@@ -21619,7 +21619,7 @@
                 <a:ea typeface="DejaVu Sans Mono"/>
                 <a:cs typeface="DejaVu Sans Mono"/>
               </a:rPr>
-              <a:t>25</a:t>
+              <a:t>24</a:t>
             </a:r>
             <a:endParaRPr sz="1275" b="1" i="0" dirty="0">
               <a:solidFill>
@@ -22659,7 +22659,7 @@
                 <a:ea typeface="DejaVu Sans Mono"/>
                 <a:cs typeface="DejaVu Sans Mono"/>
               </a:rPr>
-              <a:t>26</a:t>
+              <a:t>25</a:t>
             </a:r>
             <a:endParaRPr sz="1275" b="1" i="0" dirty="0">
               <a:solidFill>
@@ -23362,7 +23362,7 @@
                 <a:ea typeface="DejaVu Sans Mono"/>
                 <a:cs typeface="DejaVu Sans Mono"/>
               </a:rPr>
-              <a:t>27</a:t>
+              <a:t>26</a:t>
             </a:r>
             <a:endParaRPr sz="1275" b="1" i="0" dirty="0">
               <a:solidFill>
@@ -24245,7 +24245,7 @@
                 <a:ea typeface="DejaVu Sans Mono"/>
                 <a:cs typeface="DejaVu Sans Mono"/>
               </a:rPr>
-              <a:t>28</a:t>
+              <a:t>27</a:t>
             </a:r>
             <a:endParaRPr sz="1275" b="1" i="0" dirty="0">
               <a:solidFill>
@@ -25154,7 +25154,7 @@
               </a:defRPr>
             </a:pPr>
             <a:r>
-              <a:rPr sz="1275" b="1" i="0">
+              <a:rPr lang="tr-TR" sz="1275" b="1" i="0" dirty="0">
                 <a:solidFill>
                   <a:srgbClr val="6B7280"/>
                 </a:solidFill>
@@ -25162,8 +25162,16 @@
                 <a:ea typeface="DejaVu Sans Mono"/>
                 <a:cs typeface="DejaVu Sans Mono"/>
               </a:rPr>
-              <a:t>25</a:t>
-            </a:r>
+              <a:t>28</a:t>
+            </a:r>
+            <a:endParaRPr sz="1275" b="1" i="0" dirty="0">
+              <a:solidFill>
+                <a:srgbClr val="6B7280"/>
+              </a:solidFill>
+              <a:latin typeface="DejaVu Sans Mono"/>
+              <a:ea typeface="DejaVu Sans Mono"/>
+              <a:cs typeface="DejaVu Sans Mono"/>
+            </a:endParaRPr>
           </a:p>
         </p:txBody>
       </p:sp>
@@ -26372,7 +26380,7 @@
               </a:defRPr>
             </a:pPr>
             <a:r>
-              <a:rPr sz="1275" b="1" i="0">
+              <a:rPr lang="tr-TR" sz="1275" b="1" i="0" dirty="0">
                 <a:solidFill>
                   <a:srgbClr val="6B7280"/>
                 </a:solidFill>
@@ -26380,8 +26388,16 @@
                 <a:ea typeface="DejaVu Sans Mono"/>
                 <a:cs typeface="DejaVu Sans Mono"/>
               </a:rPr>
-              <a:t>26</a:t>
-            </a:r>
+              <a:t>29</a:t>
+            </a:r>
+            <a:endParaRPr sz="1275" b="1" i="0" dirty="0">
+              <a:solidFill>
+                <a:srgbClr val="6B7280"/>
+              </a:solidFill>
+              <a:latin typeface="DejaVu Sans Mono"/>
+              <a:ea typeface="DejaVu Sans Mono"/>
+              <a:cs typeface="DejaVu Sans Mono"/>
+            </a:endParaRPr>
           </a:p>
         </p:txBody>
       </p:sp>
@@ -28352,7 +28368,7 @@
               </a:defRPr>
             </a:pPr>
             <a:r>
-              <a:rPr sz="1275" b="1" i="0">
+              <a:rPr lang="tr-TR" sz="1275" b="1" dirty="0">
                 <a:solidFill>
                   <a:srgbClr val="6B7280"/>
                 </a:solidFill>
@@ -28360,8 +28376,16 @@
                 <a:ea typeface="DejaVu Sans Mono"/>
                 <a:cs typeface="DejaVu Sans Mono"/>
               </a:rPr>
-              <a:t>27</a:t>
-            </a:r>
+              <a:t>30</a:t>
+            </a:r>
+            <a:endParaRPr sz="1275" b="1" i="0" dirty="0">
+              <a:solidFill>
+                <a:srgbClr val="6B7280"/>
+              </a:solidFill>
+              <a:latin typeface="DejaVu Sans Mono"/>
+              <a:ea typeface="DejaVu Sans Mono"/>
+              <a:cs typeface="DejaVu Sans Mono"/>
+            </a:endParaRPr>
           </a:p>
         </p:txBody>
       </p:sp>
@@ -29570,7 +29594,7 @@
               </a:defRPr>
             </a:pPr>
             <a:r>
-              <a:rPr sz="1275" b="1" i="0">
+              <a:rPr lang="tr-TR" sz="1275" b="1" i="0" dirty="0">
                 <a:solidFill>
                   <a:srgbClr val="6B7280"/>
                 </a:solidFill>
@@ -29578,8 +29602,16 @@
                 <a:ea typeface="DejaVu Sans Mono"/>
                 <a:cs typeface="DejaVu Sans Mono"/>
               </a:rPr>
-              <a:t>28</a:t>
-            </a:r>
+              <a:t>31</a:t>
+            </a:r>
+            <a:endParaRPr sz="1275" b="1" i="0" dirty="0">
+              <a:solidFill>
+                <a:srgbClr val="6B7280"/>
+              </a:solidFill>
+              <a:latin typeface="DejaVu Sans Mono"/>
+              <a:ea typeface="DejaVu Sans Mono"/>
+              <a:cs typeface="DejaVu Sans Mono"/>
+            </a:endParaRPr>
           </a:p>
         </p:txBody>
       </p:sp>
@@ -30788,7 +30820,7 @@
               </a:defRPr>
             </a:pPr>
             <a:r>
-              <a:rPr sz="1275" b="1" i="0">
+              <a:rPr lang="tr-TR" sz="1275" b="1" i="0" dirty="0">
                 <a:solidFill>
                   <a:srgbClr val="6B7280"/>
                 </a:solidFill>
@@ -30796,8 +30828,16 @@
                 <a:ea typeface="DejaVu Sans Mono"/>
                 <a:cs typeface="DejaVu Sans Mono"/>
               </a:rPr>
-              <a:t>29</a:t>
-            </a:r>
+              <a:t>23</a:t>
+            </a:r>
+            <a:endParaRPr sz="1275" b="1" i="0" dirty="0">
+              <a:solidFill>
+                <a:srgbClr val="6B7280"/>
+              </a:solidFill>
+              <a:latin typeface="DejaVu Sans Mono"/>
+              <a:ea typeface="DejaVu Sans Mono"/>
+              <a:cs typeface="DejaVu Sans Mono"/>
+            </a:endParaRPr>
           </a:p>
         </p:txBody>
       </p:sp>
@@ -32006,7 +32046,7 @@
               </a:defRPr>
             </a:pPr>
             <a:r>
-              <a:rPr sz="1275" b="1" i="0">
+              <a:rPr lang="tr-TR" sz="1275" b="1" i="0" dirty="0">
                 <a:solidFill>
                   <a:srgbClr val="6B7280"/>
                 </a:solidFill>
@@ -32014,8 +32054,16 @@
                 <a:ea typeface="DejaVu Sans Mono"/>
                 <a:cs typeface="DejaVu Sans Mono"/>
               </a:rPr>
-              <a:t>30</a:t>
-            </a:r>
+              <a:t>33</a:t>
+            </a:r>
+            <a:endParaRPr sz="1275" b="1" i="0" dirty="0">
+              <a:solidFill>
+                <a:srgbClr val="6B7280"/>
+              </a:solidFill>
+              <a:latin typeface="DejaVu Sans Mono"/>
+              <a:ea typeface="DejaVu Sans Mono"/>
+              <a:cs typeface="DejaVu Sans Mono"/>
+            </a:endParaRPr>
           </a:p>
         </p:txBody>
       </p:sp>
@@ -33224,7 +33272,7 @@
               </a:defRPr>
             </a:pPr>
             <a:r>
-              <a:rPr sz="1275" b="1" i="0">
+              <a:rPr lang="tr-TR" sz="1275" b="1" dirty="0">
                 <a:solidFill>
                   <a:srgbClr val="6B7280"/>
                 </a:solidFill>
@@ -33232,8 +33280,16 @@
                 <a:ea typeface="DejaVu Sans Mono"/>
                 <a:cs typeface="DejaVu Sans Mono"/>
               </a:rPr>
-              <a:t>31</a:t>
-            </a:r>
+              <a:t>34</a:t>
+            </a:r>
+            <a:endParaRPr sz="1275" b="1" i="0" dirty="0">
+              <a:solidFill>
+                <a:srgbClr val="6B7280"/>
+              </a:solidFill>
+              <a:latin typeface="DejaVu Sans Mono"/>
+              <a:ea typeface="DejaVu Sans Mono"/>
+              <a:cs typeface="DejaVu Sans Mono"/>
+            </a:endParaRPr>
           </a:p>
         </p:txBody>
       </p:sp>
@@ -34442,7 +34498,7 @@
               </a:defRPr>
             </a:pPr>
             <a:r>
-              <a:rPr sz="1275" b="1" i="0">
+              <a:rPr lang="tr-TR" sz="1275" b="1" i="0" dirty="0">
                 <a:solidFill>
                   <a:srgbClr val="6B7280"/>
                 </a:solidFill>
@@ -34450,8 +34506,16 @@
                 <a:ea typeface="DejaVu Sans Mono"/>
                 <a:cs typeface="DejaVu Sans Mono"/>
               </a:rPr>
-              <a:t>32</a:t>
-            </a:r>
+              <a:t>35</a:t>
+            </a:r>
+            <a:endParaRPr sz="1275" b="1" i="0" dirty="0">
+              <a:solidFill>
+                <a:srgbClr val="6B7280"/>
+              </a:solidFill>
+              <a:latin typeface="DejaVu Sans Mono"/>
+              <a:ea typeface="DejaVu Sans Mono"/>
+              <a:cs typeface="DejaVu Sans Mono"/>
+            </a:endParaRPr>
           </a:p>
         </p:txBody>
       </p:sp>
@@ -35660,7 +35724,7 @@
               </a:defRPr>
             </a:pPr>
             <a:r>
-              <a:rPr sz="1275" b="1" i="0">
+              <a:rPr lang="tr-TR" sz="1275" b="1" i="0" dirty="0">
                 <a:solidFill>
                   <a:srgbClr val="6B7280"/>
                 </a:solidFill>
@@ -35668,8 +35732,16 @@
                 <a:ea typeface="DejaVu Sans Mono"/>
                 <a:cs typeface="DejaVu Sans Mono"/>
               </a:rPr>
-              <a:t>33</a:t>
-            </a:r>
+              <a:t>36</a:t>
+            </a:r>
+            <a:endParaRPr sz="1275" b="1" i="0" dirty="0">
+              <a:solidFill>
+                <a:srgbClr val="6B7280"/>
+              </a:solidFill>
+              <a:latin typeface="DejaVu Sans Mono"/>
+              <a:ea typeface="DejaVu Sans Mono"/>
+              <a:cs typeface="DejaVu Sans Mono"/>
+            </a:endParaRPr>
           </a:p>
         </p:txBody>
       </p:sp>
@@ -36878,7 +36950,7 @@
               </a:defRPr>
             </a:pPr>
             <a:r>
-              <a:rPr sz="1275" b="1" i="0">
+              <a:rPr lang="tr-TR" sz="1275" b="1" i="0" dirty="0">
                 <a:solidFill>
                   <a:srgbClr val="6B7280"/>
                 </a:solidFill>
@@ -36886,8 +36958,16 @@
                 <a:ea typeface="DejaVu Sans Mono"/>
                 <a:cs typeface="DejaVu Sans Mono"/>
               </a:rPr>
-              <a:t>35</a:t>
-            </a:r>
+              <a:t>37</a:t>
+            </a:r>
+            <a:endParaRPr sz="1275" b="1" i="0" dirty="0">
+              <a:solidFill>
+                <a:srgbClr val="6B7280"/>
+              </a:solidFill>
+              <a:latin typeface="DejaVu Sans Mono"/>
+              <a:ea typeface="DejaVu Sans Mono"/>
+              <a:cs typeface="DejaVu Sans Mono"/>
+            </a:endParaRPr>
           </a:p>
         </p:txBody>
       </p:sp>
@@ -38819,7 +38899,7 @@
               </a:defRPr>
             </a:pPr>
             <a:r>
-              <a:rPr sz="1275" b="1" i="0">
+              <a:rPr lang="tr-TR" sz="1275" b="1" i="0" dirty="0">
                 <a:solidFill>
                   <a:srgbClr val="6B7280"/>
                 </a:solidFill>
@@ -38827,8 +38907,16 @@
                 <a:ea typeface="DejaVu Sans Mono"/>
                 <a:cs typeface="DejaVu Sans Mono"/>
               </a:rPr>
-              <a:t>34</a:t>
-            </a:r>
+              <a:t>38</a:t>
+            </a:r>
+            <a:endParaRPr sz="1275" b="1" i="0" dirty="0">
+              <a:solidFill>
+                <a:srgbClr val="6B7280"/>
+              </a:solidFill>
+              <a:latin typeface="DejaVu Sans Mono"/>
+              <a:ea typeface="DejaVu Sans Mono"/>
+              <a:cs typeface="DejaVu Sans Mono"/>
+            </a:endParaRPr>
           </a:p>
         </p:txBody>
       </p:sp>
@@ -39621,7 +39709,7 @@
               </a:defRPr>
             </a:pPr>
             <a:r>
-              <a:rPr sz="1275" b="1" i="0">
+              <a:rPr lang="tr-TR" sz="1275" b="1" i="0" dirty="0">
                 <a:solidFill>
                   <a:srgbClr val="6B7280"/>
                 </a:solidFill>
@@ -39629,8 +39717,16 @@
                 <a:ea typeface="DejaVu Sans Mono"/>
                 <a:cs typeface="DejaVu Sans Mono"/>
               </a:rPr>
-              <a:t>36</a:t>
-            </a:r>
+              <a:t>39</a:t>
+            </a:r>
+            <a:endParaRPr sz="1275" b="1" i="0" dirty="0">
+              <a:solidFill>
+                <a:srgbClr val="6B7280"/>
+              </a:solidFill>
+              <a:latin typeface="DejaVu Sans Mono"/>
+              <a:ea typeface="DejaVu Sans Mono"/>
+              <a:cs typeface="DejaVu Sans Mono"/>
+            </a:endParaRPr>
           </a:p>
         </p:txBody>
       </p:sp>
@@ -40813,7 +40909,7 @@
               </a:defRPr>
             </a:pPr>
             <a:r>
-              <a:rPr sz="1275" b="1" i="0">
+              <a:rPr lang="tr-TR" sz="1275" b="1" i="0" dirty="0">
                 <a:solidFill>
                   <a:srgbClr val="8BB9F0"/>
                 </a:solidFill>
@@ -40821,8 +40917,16 @@
                 <a:ea typeface="DejaVu Sans Mono"/>
                 <a:cs typeface="DejaVu Sans Mono"/>
               </a:rPr>
-              <a:t>37</a:t>
-            </a:r>
+              <a:t>40</a:t>
+            </a:r>
+            <a:endParaRPr sz="1275" b="1" i="0" dirty="0">
+              <a:solidFill>
+                <a:srgbClr val="8BB9F0"/>
+              </a:solidFill>
+              <a:latin typeface="DejaVu Sans Mono"/>
+              <a:ea typeface="DejaVu Sans Mono"/>
+              <a:cs typeface="DejaVu Sans Mono"/>
+            </a:endParaRPr>
           </a:p>
         </p:txBody>
       </p:sp>

</xml_diff>